<commit_message>
Update presentation files with new content and visuals
</commit_message>
<xml_diff>
--- a/outputs/ieps_scf_final_presentation.pptx
+++ b/outputs/ieps_scf_final_presentation.pptx
@@ -5946,7 +5946,7 @@
                 <a:latin typeface="Aptos"/>
                 <a:cs typeface="Aptos"/>
               </a:rPr>
-              <a:t>7.0 ms</a:t>
+              <a:t>9.7 ms</a:t>
             </a:r>
           </a:p>
         </p:txBody>
@@ -20897,7 +20897,7 @@
                 <a:latin typeface="Aptos"/>
                 <a:cs typeface="Aptos"/>
               </a:rPr>
-              <a:t>7.0 ms</a:t>
+              <a:t>14.4 ms</a:t>
             </a:r>
           </a:p>
         </p:txBody>
@@ -21212,7 +21212,7 @@
                 <a:latin typeface="Aptos"/>
                 <a:cs typeface="Aptos"/>
               </a:rPr>
-              <a:t>7.0 ms</a:t>
+              <a:t>9.7 ms</a:t>
             </a:r>
           </a:p>
         </p:txBody>

</xml_diff>

<commit_message>
Update final presentation files and enhance text rendering in build script
</commit_message>
<xml_diff>
--- a/outputs/ieps_scf_final_presentation.pptx
+++ b/outputs/ieps_scf_final_presentation.pptx
@@ -8142,7 +8142,7 @@
                 <a:latin typeface="Consolas"/>
                 <a:cs typeface="Consolas"/>
               </a:rPr>
-              <a:t>    angle = 2.0 * math.pi * i / initial_scan_lines</a:t>
+              <a:t>    angle = 2.0 * math.pi * i / initial_scan_lines</a:t>
             </a:r>
           </a:p>
         </p:txBody>
@@ -8179,7 +8179,7 @@
                 <a:latin typeface="Consolas"/>
                 <a:cs typeface="Consolas"/>
               </a:rPr>
-              <a:t>    ray = sample_ray_from_center(center, angle, image.shape)</a:t>
+              <a:t>    ray = sample_ray_from_center(center, angle, image.shape)</a:t>
             </a:r>
           </a:p>
         </p:txBody>
@@ -8216,7 +8216,7 @@
                 <a:latin typeface="Consolas"/>
                 <a:cs typeface="Consolas"/>
               </a:rPr>
-              <a:t>    candidates = [p for p in ray if gradient[p[1], p[0]] &gt;= threshold]   # Eq. (3)</a:t>
+              <a:t>    candidates = [p for p in ray if gradient[p[1], p[0]] &gt;= threshold]   # Eq. (3)</a:t>
             </a:r>
           </a:p>
         </p:txBody>
@@ -8253,7 +8253,7 @@
                 <a:latin typeface="Consolas"/>
                 <a:cs typeface="Consolas"/>
               </a:rPr>
-              <a:t>    if candidates:</a:t>
+              <a:t>    if candidates:</a:t>
             </a:r>
           </a:p>
         </p:txBody>
@@ -8290,7 +8290,7 @@
                 <a:latin typeface="Consolas"/>
                 <a:cs typeface="Consolas"/>
               </a:rPr>
-              <a:t>        points.append(max(candidates, key=lambda p: distance(p, center)))</a:t>
+              <a:t>        points.append(max(candidates, key=lambda p: distance(p, center)))</a:t>
             </a:r>
           </a:p>
         </p:txBody>
@@ -8438,7 +8438,7 @@
                 <a:latin typeface="Consolas"/>
                 <a:cs typeface="Consolas"/>
               </a:rPr>
-              <a:t>    radius = max(3.0, default_scan_distance / 2.0 ** iteration)   # Eq. (7)</a:t>
+              <a:t>    radius = max(3.0, default_scan_distance / 2.0 ** iteration)   # Eq. (7)</a:t>
             </a:r>
           </a:p>
         </p:txBody>
@@ -8475,7 +8475,7 @@
                 <a:latin typeface="Consolas"/>
                 <a:cs typeface="Consolas"/>
               </a:rPr>
-              <a:t>    next_points = []</a:t>
+              <a:t>    next_points = []</a:t>
             </a:r>
           </a:p>
         </p:txBody>
@@ -8512,7 +8512,7 @@
                 <a:latin typeface="Consolas"/>
                 <a:cs typeface="Consolas"/>
               </a:rPr>
-              <a:t>    for idx in range(len(points)):</a:t>
+              <a:t>    for idx in range(len(points)):</a:t>
             </a:r>
           </a:p>
         </p:txBody>
@@ -8549,7 +8549,7 @@
                 <a:latin typeface="Consolas"/>
                 <a:cs typeface="Consolas"/>
               </a:rPr>
-              <a:t>        p1, p2 = points[idx], points[(idx + 1) % len(points)]</a:t>
+              <a:t>        p1, p2 = points[idx], points[(idx + 1) % len(points)]</a:t>
             </a:r>
           </a:p>
         </p:txBody>
@@ -8586,7 +8586,7 @@
                 <a:latin typeface="Consolas"/>
                 <a:cs typeface="Consolas"/>
               </a:rPr>
-              <a:t>        mid = midpoint(p1, p2)                                    # Eq. (5)</a:t>
+              <a:t>        mid = midpoint(p1, p2)                                    # Eq. (5)</a:t>
             </a:r>
           </a:p>
         </p:txBody>
@@ -8623,7 +8623,7 @@
                 <a:latin typeface="Consolas"/>
                 <a:cs typeface="Consolas"/>
               </a:rPr>
-              <a:t>        normal = normal_vector(p1, p2)                            # Eq. (6)</a:t>
+              <a:t>        normal = normal_vector(p1, p2)                            # Eq. (6)</a:t>
             </a:r>
           </a:p>
         </p:txBody>
@@ -8660,7 +8660,7 @@
                 <a:latin typeface="Consolas"/>
                 <a:cs typeface="Consolas"/>
               </a:rPr>
-              <a:t>        scan = sample_line_through_point(mid, normal, image.shape, radius)</a:t>
+              <a:t>        scan = sample_line_through_point(mid, normal, image.shape, radius)</a:t>
             </a:r>
           </a:p>
         </p:txBody>
@@ -8697,7 +8697,7 @@
                 <a:latin typeface="Consolas"/>
                 <a:cs typeface="Consolas"/>
               </a:rPr>
-              <a:t>        selected = select_edge_candidate(scan, gradient, threshold, fallback)</a:t>
+              <a:t>        selected = select_edge_candidate(scan, gradient, threshold, fallback)</a:t>
             </a:r>
           </a:p>
         </p:txBody>
@@ -8734,7 +8734,7 @@
                 <a:latin typeface="Consolas"/>
                 <a:cs typeface="Consolas"/>
               </a:rPr>
-              <a:t>        next_points.append(p1)</a:t>
+              <a:t>        next_points.append(p1)</a:t>
             </a:r>
           </a:p>
         </p:txBody>
@@ -8771,7 +8771,7 @@
                 <a:latin typeface="Consolas"/>
                 <a:cs typeface="Consolas"/>
               </a:rPr>
-              <a:t>        if selected is not None:</a:t>
+              <a:t>        if selected is not None:</a:t>
             </a:r>
           </a:p>
         </p:txBody>
@@ -8808,7 +8808,7 @@
                 <a:latin typeface="Consolas"/>
                 <a:cs typeface="Consolas"/>
               </a:rPr>
-              <a:t>            next_points.append(selected)    # new point stays between its parents</a:t>
+              <a:t>            next_points.append(selected)    # new point stays between its parents</a:t>
             </a:r>
           </a:p>
         </p:txBody>
@@ -8845,7 +8845,7 @@
                 <a:latin typeface="Consolas"/>
                 <a:cs typeface="Consolas"/>
               </a:rPr>
-              <a:t>    points = unique_preserve_order(next_points)      # N * 2**p  -&gt;  32 points</a:t>
+              <a:t>    points = unique_preserve_order(next_points)      # N * 2**p  -&gt;  32 points</a:t>
             </a:r>
           </a:p>
         </p:txBody>
@@ -9238,7 +9238,7 @@
                 <a:latin typeface="Consolas"/>
                 <a:cs typeface="Consolas"/>
               </a:rPr>
-              <a:t>    max_steps = max(5, math.ceil(3.0 * distance(start, target)))   # step guard</a:t>
+              <a:t>    max_steps = max(5, math.ceil(3.0 * distance(start, target)))   # step guard</a:t>
             </a:r>
           </a:p>
         </p:txBody>
@@ -9275,7 +9275,7 @@
                 <a:latin typeface="Consolas"/>
                 <a:cs typeface="Consolas"/>
               </a:rPr>
-              <a:t>    current, path, visited = start, [start], {start}</a:t>
+              <a:t>    current, path, visited = start, [start], {start}</a:t>
             </a:r>
           </a:p>
         </p:txBody>
@@ -9312,7 +9312,7 @@
                 <a:latin typeface="Consolas"/>
                 <a:cs typeface="Consolas"/>
               </a:rPr>
-              <a:t>    for _ in range(max_steps):</a:t>
+              <a:t>    for _ in range(max_steps):</a:t>
             </a:r>
           </a:p>
         </p:txBody>
@@ -9349,7 +9349,7 @@
                 <a:latin typeface="Consolas"/>
                 <a:cs typeface="Consolas"/>
               </a:rPr>
-              <a:t>        if distance(current, target) &lt;= tol:                # explicit stop rule</a:t>
+              <a:t>        if distance(current, target) &lt;= tol:                # explicit stop rule</a:t>
             </a:r>
           </a:p>
         </p:txBody>
@@ -9386,7 +9386,7 @@
                 <a:latin typeface="Consolas"/>
                 <a:cs typeface="Consolas"/>
               </a:rPr>
-              <a:t>            break</a:t>
+              <a:t>            break</a:t>
             </a:r>
           </a:p>
         </p:txBody>
@@ -9423,7 +9423,7 @@
                 <a:latin typeface="Consolas"/>
                 <a:cs typeface="Consolas"/>
               </a:rPr>
-              <a:t>        cands = directional_candidates(current, target)     # 3-pixel mask, Fig. 4</a:t>
+              <a:t>        cands = directional_candidates(current, target)     # 3-pixel mask, Fig. 4</a:t>
             </a:r>
           </a:p>
         </p:txBody>
@@ -9460,7 +9460,7 @@
                 <a:latin typeface="Consolas"/>
                 <a:cs typeface="Consolas"/>
               </a:rPr>
-              <a:t>        cands = [p for p in cands if p not in visited] or cands    # no loops</a:t>
+              <a:t>        cands = [p for p in cands if p not in visited] or cands    # no loops</a:t>
             </a:r>
           </a:p>
         </p:txBody>
@@ -9497,7 +9497,7 @@
                 <a:latin typeface="Consolas"/>
                 <a:cs typeface="Consolas"/>
               </a:rPr>
-              <a:t>        if max(grad(p) for p in cands) &lt; 1.0:               # broken edge?</a:t>
+              <a:t>        if max(grad(p) for p in cands) &lt; 1.0:               # broken edge?</a:t>
             </a:r>
           </a:p>
         </p:txBody>
@@ -9534,7 +9534,7 @@
                 <a:latin typeface="Consolas"/>
                 <a:cs typeface="Consolas"/>
               </a:rPr>
-              <a:t>            best = min(cands, key=lambda p: distance(p, target))   # fallback</a:t>
+              <a:t>            best = min(cands, key=lambda p: distance(p, target))   # fallback</a:t>
             </a:r>
           </a:p>
         </p:txBody>
@@ -9571,7 +9571,7 @@
                 <a:latin typeface="Consolas"/>
                 <a:cs typeface="Consolas"/>
               </a:rPr>
-              <a:t>        else:</a:t>
+              <a:t>        else:</a:t>
             </a:r>
           </a:p>
         </p:txBody>
@@ -9608,7 +9608,7 @@
                 <a:latin typeface="Consolas"/>
                 <a:cs typeface="Consolas"/>
               </a:rPr>
-              <a:t>            best = max(cands, key=lambda p: (</a:t>
+              <a:t>            best = max(cands, key=lambda p: (</a:t>
             </a:r>
           </a:p>
         </p:txBody>
@@ -9645,7 +9645,7 @@
                 <a:latin typeface="Consolas"/>
                 <a:cs typeface="Consolas"/>
               </a:rPr>
-              <a:t>                grad(p) / (distance(p, target) ** 2 + 1.0),  # gravity ~ Eq. (9)</a:t>
+              <a:t>                grad(p) / (distance(p, target) ** 2 + 1.0),  # gravity ~ Eq. (9)</a:t>
             </a:r>
           </a:p>
         </p:txBody>
@@ -9682,7 +9682,7 @@
                 <a:latin typeface="Consolas"/>
                 <a:cs typeface="Consolas"/>
               </a:rPr>
-              <a:t>                grad(p),                                     # tie-break: gradient</a:t>
+              <a:t>                grad(p),                                     # tie-break: gradient</a:t>
             </a:r>
           </a:p>
         </p:txBody>
@@ -9719,7 +9719,7 @@
                 <a:latin typeface="Consolas"/>
                 <a:cs typeface="Consolas"/>
               </a:rPr>
-              <a:t>                -distance(p, target)))                       # tie-break: distance</a:t>
+              <a:t>                -distance(p, target)))                       # tie-break: distance</a:t>
             </a:r>
           </a:p>
         </p:txBody>
@@ -9756,7 +9756,7 @@
                 <a:latin typeface="Consolas"/>
                 <a:cs typeface="Consolas"/>
               </a:rPr>
-              <a:t>        current = best</a:t>
+              <a:t>        current = best</a:t>
             </a:r>
           </a:p>
         </p:txBody>
@@ -9793,7 +9793,7 @@
                 <a:latin typeface="Consolas"/>
                 <a:cs typeface="Consolas"/>
               </a:rPr>
-              <a:t>        path.append(best)</a:t>
+              <a:t>        path.append(best)</a:t>
             </a:r>
           </a:p>
         </p:txBody>
@@ -9830,7 +9830,7 @@
                 <a:latin typeface="Consolas"/>
                 <a:cs typeface="Consolas"/>
               </a:rPr>
-              <a:t>        visited.add(best)</a:t>
+              <a:t>        visited.add(best)</a:t>
             </a:r>
           </a:p>
         </p:txBody>
@@ -9867,7 +9867,7 @@
                 <a:latin typeface="Consolas"/>
                 <a:cs typeface="Consolas"/>
               </a:rPr>
-              <a:t>    return path</a:t>
+              <a:t>    return path</a:t>
             </a:r>
           </a:p>
         </p:txBody>
@@ -10015,7 +10015,7 @@
                 <a:latin typeface="Consolas"/>
                 <a:cs typeface="Consolas"/>
               </a:rPr>
-              <a:t>    contour += trace_segment_greedy(grad, points[i], points[(i + 1) % len(points)])</a:t>
+              <a:t>    contour += trace_segment_greedy(grad, points[i], points[(i + 1) % len(points)])</a:t>
             </a:r>
           </a:p>
         </p:txBody>
@@ -13350,7 +13350,7 @@
         <p:spPr>
           <a:xfrm>
             <a:off x="6819900" y="4876800"/>
-            <a:ext cx="4762500" cy="1047750"/>
+            <a:ext cx="4762500" cy="1181100"/>
           </a:xfrm>
           <a:prstGeom prst="rect">
             <a:avLst/>
@@ -13374,7 +13374,7 @@
         <p:spPr>
           <a:xfrm>
             <a:off x="6819900" y="4876800"/>
-            <a:ext cx="57150" cy="1047750"/>
+            <a:ext cx="57150" cy="1181100"/>
           </a:xfrm>
           <a:prstGeom prst="rect">
             <a:avLst/>
@@ -13435,7 +13435,7 @@
         <p:spPr>
           <a:xfrm>
             <a:off x="6991350" y="5295900"/>
-            <a:ext cx="4457700" cy="514350"/>
+            <a:ext cx="4457700" cy="647700"/>
           </a:xfrm>
           <a:prstGeom prst="rect">
             <a:avLst/>
@@ -13458,7 +13458,7 @@
                 <a:latin typeface="Aptos"/>
                 <a:cs typeface="Aptos"/>
               </a:rPr>
-              <a:t>Real vase (Otsu proxy mask): paper-mode F1 93.8% in 14.8 ms. Yuen/Snake/Chen comparisons are labeled approximations; on these synthetic shapes they tie or nearly tie (Chen = proposed SCF at every SNR), so they are context, not evidence of the paper's reported gaps.</a:t>
+              <a:t>Real vase (Otsu proxy mask): paper-mode F1 93.8%. Yuen/Snake/Chen comparisons are labeled approximations; on these synthetic shapes they tie or nearly tie (Chen = proposed SCF at every SNR), so they are context, not evidence of the paper's reported gaps.</a:t>
             </a:r>
           </a:p>
         </p:txBody>

</xml_diff>

<commit_message>
Update final presentation files and enhance slide content for clarity
</commit_message>
<xml_diff>
--- a/outputs/ieps_scf_final_presentation.pptx
+++ b/outputs/ieps_scf_final_presentation.pptx
@@ -15,6 +15,7 @@
     <p:sldId id="263" r:id="rId9"/>
     <p:sldId id="264" r:id="rId10"/>
     <p:sldId id="265" r:id="rId11"/>
+    <p:sldId id="266" r:id="rId12"/>
   </p:sldIdLst>
   <p:sldSz cx="12192000" cy="6858000" type="wide"/>
   <p:notesSz cx="6858000" cy="9144000"/>
@@ -644,7 +645,7 @@
                 <a:latin typeface="Aptos"/>
                 <a:cs typeface="Aptos"/>
               </a:rPr>
-              <a:t>CONCLUSION</a:t>
+              <a:t>RESULTS - REAL IMAGE</a:t>
             </a:r>
           </a:p>
         </p:txBody>
@@ -681,7 +682,7 @@
                 <a:latin typeface="Aptos"/>
                 <a:cs typeface="Aptos"/>
               </a:rPr>
-              <a:t>The method reproduces - once the missing rules are written down</a:t>
+              <a:t>Real vase: the paper's qualitative test</a:t>
             </a:r>
           </a:p>
         </p:txBody>
@@ -718,7 +719,7 @@
                 <a:latin typeface="Aptos"/>
                 <a:cs typeface="Aptos"/>
               </a:rPr>
-              <a:t>The reproducibility audit is the contribution: assumptions were made explicit, implemented, and measured.</a:t>
+              <a:t>data/vase.png with an Otsu-estimated proxy mask - metrics are qualitative support, not ground-truth evaluation.</a:t>
             </a:r>
           </a:p>
         </p:txBody>
@@ -747,6 +748,1421 @@
           </a:ln>
         </p:spPr>
       </p:sp>
+      <p:pic>
+        <p:nvPicPr>
+          <p:cNvPr id="7" name="image" descr="panel.png"/>
+          <p:cNvPicPr/>
+          <p:nvPr/>
+        </p:nvPicPr>
+        <p:blipFill>
+          <a:blip r:embed="rId1"/>
+          <a:stretch>
+            <a:fillRect/>
+          </a:stretch>
+        </p:blipFill>
+        <p:spPr>
+          <a:xfrm>
+            <a:off x="609600" y="1804988"/>
+            <a:ext cx="10972800" cy="2143125"/>
+          </a:xfrm>
+          <a:prstGeom prst="rect">
+            <a:avLst/>
+          </a:prstGeom>
+        </p:spPr>
+      </p:pic>
+      <p:sp>
+        <p:nvSpPr>
+          <p:cNvPr id="8" name="text"/>
+          <p:cNvSpPr txBox="1"/>
+          <p:nvPr/>
+        </p:nvSpPr>
+        <p:spPr>
+          <a:xfrm>
+            <a:off x="609600" y="4210050"/>
+            <a:ext cx="10972800" cy="209550"/>
+          </a:xfrm>
+          <a:prstGeom prst="rect">
+            <a:avLst/>
+          </a:prstGeom>
+          <a:noFill/>
+          <a:ln>
+            <a:noFill/>
+          </a:ln>
+        </p:spPr>
+        <p:txBody>
+          <a:bodyPr wrap="square" anchor="t" lIns="0" tIns="0" rIns="0" bIns="0"/>
+          <a:lstStyle/>
+          <a:p>
+            <a:pPr algn="ctr"/>
+            <a:r>
+              <a:rPr lang="en-US" sz="1100" dirty="0">
+                <a:solidFill>
+                  <a:srgbClr val="5B6472"/>
+                </a:solidFill>
+                <a:latin typeface="Aptos"/>
+                <a:cs typeface="Aptos"/>
+              </a:rPr>
+              <a:t>Paper-mode pipeline on the real vase: input, Sobel gradient, center of gravity, 32 IEPS points, SCF contour, proxy ground truth</a:t>
+            </a:r>
+          </a:p>
+        </p:txBody>
+      </p:sp>
+      <p:sp>
+        <p:nvSpPr>
+          <p:cNvPr id="9" name="rect"/>
+          <p:cNvSpPr/>
+          <p:nvPr/>
+        </p:nvSpPr>
+        <p:spPr>
+          <a:xfrm>
+            <a:off x="609600" y="4629150"/>
+            <a:ext cx="2628900" cy="304800"/>
+          </a:xfrm>
+          <a:prstGeom prst="rect">
+            <a:avLst/>
+          </a:prstGeom>
+          <a:solidFill>
+            <a:srgbClr val="101418"/>
+          </a:solidFill>
+          <a:ln w="9525">
+            <a:solidFill>
+              <a:srgbClr val="101418"/>
+            </a:solidFill>
+          </a:ln>
+        </p:spPr>
+      </p:sp>
+      <p:sp>
+        <p:nvSpPr>
+          <p:cNvPr id="10" name="text"/>
+          <p:cNvSpPr txBox="1"/>
+          <p:nvPr/>
+        </p:nvSpPr>
+        <p:spPr>
+          <a:xfrm>
+            <a:off x="685800" y="4686300"/>
+            <a:ext cx="2476500" cy="228600"/>
+          </a:xfrm>
+          <a:prstGeom prst="rect">
+            <a:avLst/>
+          </a:prstGeom>
+          <a:noFill/>
+          <a:ln>
+            <a:noFill/>
+          </a:ln>
+        </p:spPr>
+        <p:txBody>
+          <a:bodyPr wrap="square" anchor="ctr" lIns="0" tIns="0" rIns="0" bIns="0"/>
+          <a:lstStyle/>
+          <a:p>
+            <a:pPr algn="l"/>
+            <a:r>
+              <a:rPr lang="en-US" sz="1200" b="1" dirty="0">
+                <a:solidFill>
+                  <a:srgbClr val="FFFFFF"/>
+                </a:solidFill>
+                <a:latin typeface="Aptos"/>
+                <a:cs typeface="Aptos"/>
+              </a:rPr>
+              <a:t>Configuration</a:t>
+            </a:r>
+          </a:p>
+        </p:txBody>
+      </p:sp>
+      <p:sp>
+        <p:nvSpPr>
+          <p:cNvPr id="11" name="rect"/>
+          <p:cNvSpPr/>
+          <p:nvPr/>
+        </p:nvSpPr>
+        <p:spPr>
+          <a:xfrm>
+            <a:off x="3238500" y="4629150"/>
+            <a:ext cx="1183005" cy="304800"/>
+          </a:xfrm>
+          <a:prstGeom prst="rect">
+            <a:avLst/>
+          </a:prstGeom>
+          <a:solidFill>
+            <a:srgbClr val="101418"/>
+          </a:solidFill>
+          <a:ln w="9525">
+            <a:solidFill>
+              <a:srgbClr val="101418"/>
+            </a:solidFill>
+          </a:ln>
+        </p:spPr>
+      </p:sp>
+      <p:sp>
+        <p:nvSpPr>
+          <p:cNvPr id="12" name="text"/>
+          <p:cNvSpPr txBox="1"/>
+          <p:nvPr/>
+        </p:nvSpPr>
+        <p:spPr>
+          <a:xfrm>
+            <a:off x="3314700" y="4686300"/>
+            <a:ext cx="1030605" cy="228600"/>
+          </a:xfrm>
+          <a:prstGeom prst="rect">
+            <a:avLst/>
+          </a:prstGeom>
+          <a:noFill/>
+          <a:ln>
+            <a:noFill/>
+          </a:ln>
+        </p:spPr>
+        <p:txBody>
+          <a:bodyPr wrap="square" anchor="ctr" lIns="0" tIns="0" rIns="0" bIns="0"/>
+          <a:lstStyle/>
+          <a:p>
+            <a:pPr algn="l"/>
+            <a:r>
+              <a:rPr lang="en-US" sz="1200" b="1" dirty="0">
+                <a:solidFill>
+                  <a:srgbClr val="FFFFFF"/>
+                </a:solidFill>
+                <a:latin typeface="Aptos"/>
+                <a:cs typeface="Aptos"/>
+              </a:rPr>
+              <a:t>IEPS acc</a:t>
+            </a:r>
+          </a:p>
+        </p:txBody>
+      </p:sp>
+      <p:sp>
+        <p:nvSpPr>
+          <p:cNvPr id="13" name="rect"/>
+          <p:cNvSpPr/>
+          <p:nvPr/>
+        </p:nvSpPr>
+        <p:spPr>
+          <a:xfrm>
+            <a:off x="4421505" y="4629150"/>
+            <a:ext cx="1183005" cy="304800"/>
+          </a:xfrm>
+          <a:prstGeom prst="rect">
+            <a:avLst/>
+          </a:prstGeom>
+          <a:solidFill>
+            <a:srgbClr val="101418"/>
+          </a:solidFill>
+          <a:ln w="9525">
+            <a:solidFill>
+              <a:srgbClr val="101418"/>
+            </a:solidFill>
+          </a:ln>
+        </p:spPr>
+      </p:sp>
+      <p:sp>
+        <p:nvSpPr>
+          <p:cNvPr id="14" name="text"/>
+          <p:cNvSpPr txBox="1"/>
+          <p:nvPr/>
+        </p:nvSpPr>
+        <p:spPr>
+          <a:xfrm>
+            <a:off x="4497705" y="4686300"/>
+            <a:ext cx="1030605" cy="228600"/>
+          </a:xfrm>
+          <a:prstGeom prst="rect">
+            <a:avLst/>
+          </a:prstGeom>
+          <a:noFill/>
+          <a:ln>
+            <a:noFill/>
+          </a:ln>
+        </p:spPr>
+        <p:txBody>
+          <a:bodyPr wrap="square" anchor="ctr" lIns="0" tIns="0" rIns="0" bIns="0"/>
+          <a:lstStyle/>
+          <a:p>
+            <a:pPr algn="l"/>
+            <a:r>
+              <a:rPr lang="en-US" sz="1200" b="1" dirty="0">
+                <a:solidFill>
+                  <a:srgbClr val="FFFFFF"/>
+                </a:solidFill>
+                <a:latin typeface="Aptos"/>
+                <a:cs typeface="Aptos"/>
+              </a:rPr>
+              <a:t>F1 (proxy)</a:t>
+            </a:r>
+          </a:p>
+        </p:txBody>
+      </p:sp>
+      <p:sp>
+        <p:nvSpPr>
+          <p:cNvPr id="15" name="rect"/>
+          <p:cNvSpPr/>
+          <p:nvPr/>
+        </p:nvSpPr>
+        <p:spPr>
+          <a:xfrm>
+            <a:off x="5604510" y="4629150"/>
+            <a:ext cx="1577340" cy="304800"/>
+          </a:xfrm>
+          <a:prstGeom prst="rect">
+            <a:avLst/>
+          </a:prstGeom>
+          <a:solidFill>
+            <a:srgbClr val="101418"/>
+          </a:solidFill>
+          <a:ln w="9525">
+            <a:solidFill>
+              <a:srgbClr val="101418"/>
+            </a:solidFill>
+          </a:ln>
+        </p:spPr>
+      </p:sp>
+      <p:sp>
+        <p:nvSpPr>
+          <p:cNvPr id="16" name="text"/>
+          <p:cNvSpPr txBox="1"/>
+          <p:nvPr/>
+        </p:nvSpPr>
+        <p:spPr>
+          <a:xfrm>
+            <a:off x="5680710" y="4686300"/>
+            <a:ext cx="1424940" cy="228600"/>
+          </a:xfrm>
+          <a:prstGeom prst="rect">
+            <a:avLst/>
+          </a:prstGeom>
+          <a:noFill/>
+          <a:ln>
+            <a:noFill/>
+          </a:ln>
+        </p:spPr>
+        <p:txBody>
+          <a:bodyPr wrap="square" anchor="ctr" lIns="0" tIns="0" rIns="0" bIns="0"/>
+          <a:lstStyle/>
+          <a:p>
+            <a:pPr algn="l"/>
+            <a:r>
+              <a:rPr lang="en-US" sz="1200" b="1" dirty="0">
+                <a:solidFill>
+                  <a:srgbClr val="FFFFFF"/>
+                </a:solidFill>
+                <a:latin typeface="Aptos"/>
+                <a:cs typeface="Aptos"/>
+              </a:rPr>
+              <a:t>IEPS+SCF time</a:t>
+            </a:r>
+          </a:p>
+        </p:txBody>
+      </p:sp>
+      <p:sp>
+        <p:nvSpPr>
+          <p:cNvPr id="17" name="rect"/>
+          <p:cNvSpPr/>
+          <p:nvPr/>
+        </p:nvSpPr>
+        <p:spPr>
+          <a:xfrm>
+            <a:off x="609600" y="4933950"/>
+            <a:ext cx="2628900" cy="330200"/>
+          </a:xfrm>
+          <a:prstGeom prst="rect">
+            <a:avLst/>
+          </a:prstGeom>
+          <a:solidFill>
+            <a:srgbClr val="FFFFFF"/>
+          </a:solidFill>
+          <a:ln w="9525">
+            <a:solidFill>
+              <a:srgbClr val="D7D7CC"/>
+            </a:solidFill>
+          </a:ln>
+        </p:spPr>
+      </p:sp>
+      <p:sp>
+        <p:nvSpPr>
+          <p:cNvPr id="18" name="text"/>
+          <p:cNvSpPr txBox="1"/>
+          <p:nvPr/>
+        </p:nvSpPr>
+        <p:spPr>
+          <a:xfrm>
+            <a:off x="685800" y="4981575"/>
+            <a:ext cx="2476500" cy="254000"/>
+          </a:xfrm>
+          <a:prstGeom prst="rect">
+            <a:avLst/>
+          </a:prstGeom>
+          <a:noFill/>
+          <a:ln>
+            <a:noFill/>
+          </a:ln>
+        </p:spPr>
+        <p:txBody>
+          <a:bodyPr wrap="square" anchor="ctr" lIns="0" tIns="0" rIns="0" bIns="0"/>
+          <a:lstStyle/>
+          <a:p>
+            <a:pPr algn="l"/>
+            <a:r>
+              <a:rPr lang="en-US" sz="1200" b="1" dirty="0">
+                <a:solidFill>
+                  <a:srgbClr val="111827"/>
+                </a:solidFill>
+                <a:latin typeface="Aptos"/>
+                <a:cs typeface="Aptos"/>
+              </a:rPr>
+              <a:t>paper IEPS + greedy SCF</a:t>
+            </a:r>
+          </a:p>
+        </p:txBody>
+      </p:sp>
+      <p:sp>
+        <p:nvSpPr>
+          <p:cNvPr id="19" name="rect"/>
+          <p:cNvSpPr/>
+          <p:nvPr/>
+        </p:nvSpPr>
+        <p:spPr>
+          <a:xfrm>
+            <a:off x="3238500" y="4933950"/>
+            <a:ext cx="1183005" cy="330200"/>
+          </a:xfrm>
+          <a:prstGeom prst="rect">
+            <a:avLst/>
+          </a:prstGeom>
+          <a:solidFill>
+            <a:srgbClr val="FFFFFF"/>
+          </a:solidFill>
+          <a:ln w="9525">
+            <a:solidFill>
+              <a:srgbClr val="D7D7CC"/>
+            </a:solidFill>
+          </a:ln>
+        </p:spPr>
+      </p:sp>
+      <p:sp>
+        <p:nvSpPr>
+          <p:cNvPr id="20" name="text"/>
+          <p:cNvSpPr txBox="1"/>
+          <p:nvPr/>
+        </p:nvSpPr>
+        <p:spPr>
+          <a:xfrm>
+            <a:off x="3314700" y="4981575"/>
+            <a:ext cx="1030605" cy="254000"/>
+          </a:xfrm>
+          <a:prstGeom prst="rect">
+            <a:avLst/>
+          </a:prstGeom>
+          <a:noFill/>
+          <a:ln>
+            <a:noFill/>
+          </a:ln>
+        </p:spPr>
+        <p:txBody>
+          <a:bodyPr wrap="square" anchor="ctr" lIns="0" tIns="0" rIns="0" bIns="0"/>
+          <a:lstStyle/>
+          <a:p>
+            <a:pPr algn="l"/>
+            <a:r>
+              <a:rPr lang="en-US" sz="1200" dirty="0">
+                <a:solidFill>
+                  <a:srgbClr val="5B6472"/>
+                </a:solidFill>
+                <a:latin typeface="Aptos"/>
+                <a:cs typeface="Aptos"/>
+              </a:rPr>
+              <a:t>96.9%</a:t>
+            </a:r>
+          </a:p>
+        </p:txBody>
+      </p:sp>
+      <p:sp>
+        <p:nvSpPr>
+          <p:cNvPr id="21" name="rect"/>
+          <p:cNvSpPr/>
+          <p:nvPr/>
+        </p:nvSpPr>
+        <p:spPr>
+          <a:xfrm>
+            <a:off x="4421505" y="4933950"/>
+            <a:ext cx="1183005" cy="330200"/>
+          </a:xfrm>
+          <a:prstGeom prst="rect">
+            <a:avLst/>
+          </a:prstGeom>
+          <a:solidFill>
+            <a:srgbClr val="FFFFFF"/>
+          </a:solidFill>
+          <a:ln w="9525">
+            <a:solidFill>
+              <a:srgbClr val="D7D7CC"/>
+            </a:solidFill>
+          </a:ln>
+        </p:spPr>
+      </p:sp>
+      <p:sp>
+        <p:nvSpPr>
+          <p:cNvPr id="22" name="text"/>
+          <p:cNvSpPr txBox="1"/>
+          <p:nvPr/>
+        </p:nvSpPr>
+        <p:spPr>
+          <a:xfrm>
+            <a:off x="4497705" y="4981575"/>
+            <a:ext cx="1030605" cy="254000"/>
+          </a:xfrm>
+          <a:prstGeom prst="rect">
+            <a:avLst/>
+          </a:prstGeom>
+          <a:noFill/>
+          <a:ln>
+            <a:noFill/>
+          </a:ln>
+        </p:spPr>
+        <p:txBody>
+          <a:bodyPr wrap="square" anchor="ctr" lIns="0" tIns="0" rIns="0" bIns="0"/>
+          <a:lstStyle/>
+          <a:p>
+            <a:pPr algn="l"/>
+            <a:r>
+              <a:rPr lang="en-US" sz="1200" dirty="0">
+                <a:solidFill>
+                  <a:srgbClr val="5B6472"/>
+                </a:solidFill>
+                <a:latin typeface="Aptos"/>
+                <a:cs typeface="Aptos"/>
+              </a:rPr>
+              <a:t>93.8%</a:t>
+            </a:r>
+          </a:p>
+        </p:txBody>
+      </p:sp>
+      <p:sp>
+        <p:nvSpPr>
+          <p:cNvPr id="23" name="rect"/>
+          <p:cNvSpPr/>
+          <p:nvPr/>
+        </p:nvSpPr>
+        <p:spPr>
+          <a:xfrm>
+            <a:off x="5604510" y="4933950"/>
+            <a:ext cx="1577340" cy="330200"/>
+          </a:xfrm>
+          <a:prstGeom prst="rect">
+            <a:avLst/>
+          </a:prstGeom>
+          <a:solidFill>
+            <a:srgbClr val="FFFFFF"/>
+          </a:solidFill>
+          <a:ln w="9525">
+            <a:solidFill>
+              <a:srgbClr val="D7D7CC"/>
+            </a:solidFill>
+          </a:ln>
+        </p:spPr>
+      </p:sp>
+      <p:sp>
+        <p:nvSpPr>
+          <p:cNvPr id="24" name="text"/>
+          <p:cNvSpPr txBox="1"/>
+          <p:nvPr/>
+        </p:nvSpPr>
+        <p:spPr>
+          <a:xfrm>
+            <a:off x="5680710" y="4981575"/>
+            <a:ext cx="1424940" cy="254000"/>
+          </a:xfrm>
+          <a:prstGeom prst="rect">
+            <a:avLst/>
+          </a:prstGeom>
+          <a:noFill/>
+          <a:ln>
+            <a:noFill/>
+          </a:ln>
+        </p:spPr>
+        <p:txBody>
+          <a:bodyPr wrap="square" anchor="ctr" lIns="0" tIns="0" rIns="0" bIns="0"/>
+          <a:lstStyle/>
+          <a:p>
+            <a:pPr algn="l"/>
+            <a:r>
+              <a:rPr lang="en-US" sz="1200" dirty="0">
+                <a:solidFill>
+                  <a:srgbClr val="5B6472"/>
+                </a:solidFill>
+                <a:latin typeface="Aptos"/>
+                <a:cs typeface="Aptos"/>
+              </a:rPr>
+              <a:t>14.8 ms</a:t>
+            </a:r>
+          </a:p>
+        </p:txBody>
+      </p:sp>
+      <p:sp>
+        <p:nvSpPr>
+          <p:cNvPr id="25" name="rect"/>
+          <p:cNvSpPr/>
+          <p:nvPr/>
+        </p:nvSpPr>
+        <p:spPr>
+          <a:xfrm>
+            <a:off x="609600" y="5264150"/>
+            <a:ext cx="2628900" cy="330200"/>
+          </a:xfrm>
+          <a:prstGeom prst="rect">
+            <a:avLst/>
+          </a:prstGeom>
+          <a:solidFill>
+            <a:srgbClr val="F1F5F2"/>
+          </a:solidFill>
+          <a:ln w="9525">
+            <a:solidFill>
+              <a:srgbClr val="D7D7CC"/>
+            </a:solidFill>
+          </a:ln>
+        </p:spPr>
+      </p:sp>
+      <p:sp>
+        <p:nvSpPr>
+          <p:cNvPr id="26" name="text"/>
+          <p:cNvSpPr txBox="1"/>
+          <p:nvPr/>
+        </p:nvSpPr>
+        <p:spPr>
+          <a:xfrm>
+            <a:off x="685800" y="5311775"/>
+            <a:ext cx="2476500" cy="254000"/>
+          </a:xfrm>
+          <a:prstGeom prst="rect">
+            <a:avLst/>
+          </a:prstGeom>
+          <a:noFill/>
+          <a:ln>
+            <a:noFill/>
+          </a:ln>
+        </p:spPr>
+        <p:txBody>
+          <a:bodyPr wrap="square" anchor="ctr" lIns="0" tIns="0" rIns="0" bIns="0"/>
+          <a:lstStyle/>
+          <a:p>
+            <a:pPr algn="l"/>
+            <a:r>
+              <a:rPr lang="en-US" sz="1200" b="1" dirty="0">
+                <a:solidFill>
+                  <a:srgbClr val="111827"/>
+                </a:solidFill>
+                <a:latin typeface="Aptos"/>
+                <a:cs typeface="Aptos"/>
+              </a:rPr>
+              <a:t>paper IEPS + graph SCF (ext.)</a:t>
+            </a:r>
+          </a:p>
+        </p:txBody>
+      </p:sp>
+      <p:sp>
+        <p:nvSpPr>
+          <p:cNvPr id="27" name="rect"/>
+          <p:cNvSpPr/>
+          <p:nvPr/>
+        </p:nvSpPr>
+        <p:spPr>
+          <a:xfrm>
+            <a:off x="3238500" y="5264150"/>
+            <a:ext cx="1183005" cy="330200"/>
+          </a:xfrm>
+          <a:prstGeom prst="rect">
+            <a:avLst/>
+          </a:prstGeom>
+          <a:solidFill>
+            <a:srgbClr val="F1F5F2"/>
+          </a:solidFill>
+          <a:ln w="9525">
+            <a:solidFill>
+              <a:srgbClr val="D7D7CC"/>
+            </a:solidFill>
+          </a:ln>
+        </p:spPr>
+      </p:sp>
+      <p:sp>
+        <p:nvSpPr>
+          <p:cNvPr id="28" name="text"/>
+          <p:cNvSpPr txBox="1"/>
+          <p:nvPr/>
+        </p:nvSpPr>
+        <p:spPr>
+          <a:xfrm>
+            <a:off x="3314700" y="5311775"/>
+            <a:ext cx="1030605" cy="254000"/>
+          </a:xfrm>
+          <a:prstGeom prst="rect">
+            <a:avLst/>
+          </a:prstGeom>
+          <a:noFill/>
+          <a:ln>
+            <a:noFill/>
+          </a:ln>
+        </p:spPr>
+        <p:txBody>
+          <a:bodyPr wrap="square" anchor="ctr" lIns="0" tIns="0" rIns="0" bIns="0"/>
+          <a:lstStyle/>
+          <a:p>
+            <a:pPr algn="l"/>
+            <a:r>
+              <a:rPr lang="en-US" sz="1200" dirty="0">
+                <a:solidFill>
+                  <a:srgbClr val="5B6472"/>
+                </a:solidFill>
+                <a:latin typeface="Aptos"/>
+                <a:cs typeface="Aptos"/>
+              </a:rPr>
+              <a:t>96.9%</a:t>
+            </a:r>
+          </a:p>
+        </p:txBody>
+      </p:sp>
+      <p:sp>
+        <p:nvSpPr>
+          <p:cNvPr id="29" name="rect"/>
+          <p:cNvSpPr/>
+          <p:nvPr/>
+        </p:nvSpPr>
+        <p:spPr>
+          <a:xfrm>
+            <a:off x="4421505" y="5264150"/>
+            <a:ext cx="1183005" cy="330200"/>
+          </a:xfrm>
+          <a:prstGeom prst="rect">
+            <a:avLst/>
+          </a:prstGeom>
+          <a:solidFill>
+            <a:srgbClr val="F1F5F2"/>
+          </a:solidFill>
+          <a:ln w="9525">
+            <a:solidFill>
+              <a:srgbClr val="D7D7CC"/>
+            </a:solidFill>
+          </a:ln>
+        </p:spPr>
+      </p:sp>
+      <p:sp>
+        <p:nvSpPr>
+          <p:cNvPr id="30" name="text"/>
+          <p:cNvSpPr txBox="1"/>
+          <p:nvPr/>
+        </p:nvSpPr>
+        <p:spPr>
+          <a:xfrm>
+            <a:off x="4497705" y="5311775"/>
+            <a:ext cx="1030605" cy="254000"/>
+          </a:xfrm>
+          <a:prstGeom prst="rect">
+            <a:avLst/>
+          </a:prstGeom>
+          <a:noFill/>
+          <a:ln>
+            <a:noFill/>
+          </a:ln>
+        </p:spPr>
+        <p:txBody>
+          <a:bodyPr wrap="square" anchor="ctr" lIns="0" tIns="0" rIns="0" bIns="0"/>
+          <a:lstStyle/>
+          <a:p>
+            <a:pPr algn="l"/>
+            <a:r>
+              <a:rPr lang="en-US" sz="1200" dirty="0">
+                <a:solidFill>
+                  <a:srgbClr val="5B6472"/>
+                </a:solidFill>
+                <a:latin typeface="Aptos"/>
+                <a:cs typeface="Aptos"/>
+              </a:rPr>
+              <a:t>94.5%</a:t>
+            </a:r>
+          </a:p>
+        </p:txBody>
+      </p:sp>
+      <p:sp>
+        <p:nvSpPr>
+          <p:cNvPr id="31" name="rect"/>
+          <p:cNvSpPr/>
+          <p:nvPr/>
+        </p:nvSpPr>
+        <p:spPr>
+          <a:xfrm>
+            <a:off x="5604510" y="5264150"/>
+            <a:ext cx="1577340" cy="330200"/>
+          </a:xfrm>
+          <a:prstGeom prst="rect">
+            <a:avLst/>
+          </a:prstGeom>
+          <a:solidFill>
+            <a:srgbClr val="F1F5F2"/>
+          </a:solidFill>
+          <a:ln w="9525">
+            <a:solidFill>
+              <a:srgbClr val="D7D7CC"/>
+            </a:solidFill>
+          </a:ln>
+        </p:spPr>
+      </p:sp>
+      <p:sp>
+        <p:nvSpPr>
+          <p:cNvPr id="32" name="text"/>
+          <p:cNvSpPr txBox="1"/>
+          <p:nvPr/>
+        </p:nvSpPr>
+        <p:spPr>
+          <a:xfrm>
+            <a:off x="5680710" y="5311775"/>
+            <a:ext cx="1424940" cy="254000"/>
+          </a:xfrm>
+          <a:prstGeom prst="rect">
+            <a:avLst/>
+          </a:prstGeom>
+          <a:noFill/>
+          <a:ln>
+            <a:noFill/>
+          </a:ln>
+        </p:spPr>
+        <p:txBody>
+          <a:bodyPr wrap="square" anchor="ctr" lIns="0" tIns="0" rIns="0" bIns="0"/>
+          <a:lstStyle/>
+          <a:p>
+            <a:pPr algn="l"/>
+            <a:r>
+              <a:rPr lang="en-US" sz="1200" dirty="0">
+                <a:solidFill>
+                  <a:srgbClr val="5B6472"/>
+                </a:solidFill>
+                <a:latin typeface="Aptos"/>
+                <a:cs typeface="Aptos"/>
+              </a:rPr>
+              <a:t>136.7 ms</a:t>
+            </a:r>
+          </a:p>
+        </p:txBody>
+      </p:sp>
+      <p:sp>
+        <p:nvSpPr>
+          <p:cNvPr id="33" name="rect"/>
+          <p:cNvSpPr/>
+          <p:nvPr/>
+        </p:nvSpPr>
+        <p:spPr>
+          <a:xfrm>
+            <a:off x="609600" y="5594350"/>
+            <a:ext cx="2628900" cy="330200"/>
+          </a:xfrm>
+          <a:prstGeom prst="rect">
+            <a:avLst/>
+          </a:prstGeom>
+          <a:solidFill>
+            <a:srgbClr val="FFFFFF"/>
+          </a:solidFill>
+          <a:ln w="9525">
+            <a:solidFill>
+              <a:srgbClr val="D7D7CC"/>
+            </a:solidFill>
+          </a:ln>
+        </p:spPr>
+      </p:sp>
+      <p:sp>
+        <p:nvSpPr>
+          <p:cNvPr id="34" name="text"/>
+          <p:cNvSpPr txBox="1"/>
+          <p:nvPr/>
+        </p:nvSpPr>
+        <p:spPr>
+          <a:xfrm>
+            <a:off x="685800" y="5641975"/>
+            <a:ext cx="2476500" cy="254000"/>
+          </a:xfrm>
+          <a:prstGeom prst="rect">
+            <a:avLst/>
+          </a:prstGeom>
+          <a:noFill/>
+          <a:ln>
+            <a:noFill/>
+          </a:ln>
+        </p:spPr>
+        <p:txBody>
+          <a:bodyPr wrap="square" anchor="ctr" lIns="0" tIns="0" rIns="0" bIns="0"/>
+          <a:lstStyle/>
+          <a:p>
+            <a:pPr algn="l"/>
+            <a:r>
+              <a:rPr lang="en-US" sz="1200" b="1" dirty="0">
+                <a:solidFill>
+                  <a:srgbClr val="111827"/>
+                </a:solidFill>
+                <a:latin typeface="Aptos"/>
+                <a:cs typeface="Aptos"/>
+              </a:rPr>
+              <a:t>improved IEPS + greedy SCF (ext.)</a:t>
+            </a:r>
+          </a:p>
+        </p:txBody>
+      </p:sp>
+      <p:sp>
+        <p:nvSpPr>
+          <p:cNvPr id="35" name="rect"/>
+          <p:cNvSpPr/>
+          <p:nvPr/>
+        </p:nvSpPr>
+        <p:spPr>
+          <a:xfrm>
+            <a:off x="3238500" y="5594350"/>
+            <a:ext cx="1183005" cy="330200"/>
+          </a:xfrm>
+          <a:prstGeom prst="rect">
+            <a:avLst/>
+          </a:prstGeom>
+          <a:solidFill>
+            <a:srgbClr val="FFFFFF"/>
+          </a:solidFill>
+          <a:ln w="9525">
+            <a:solidFill>
+              <a:srgbClr val="D7D7CC"/>
+            </a:solidFill>
+          </a:ln>
+        </p:spPr>
+      </p:sp>
+      <p:sp>
+        <p:nvSpPr>
+          <p:cNvPr id="36" name="text"/>
+          <p:cNvSpPr txBox="1"/>
+          <p:nvPr/>
+        </p:nvSpPr>
+        <p:spPr>
+          <a:xfrm>
+            <a:off x="3314700" y="5641975"/>
+            <a:ext cx="1030605" cy="254000"/>
+          </a:xfrm>
+          <a:prstGeom prst="rect">
+            <a:avLst/>
+          </a:prstGeom>
+          <a:noFill/>
+          <a:ln>
+            <a:noFill/>
+          </a:ln>
+        </p:spPr>
+        <p:txBody>
+          <a:bodyPr wrap="square" anchor="ctr" lIns="0" tIns="0" rIns="0" bIns="0"/>
+          <a:lstStyle/>
+          <a:p>
+            <a:pPr algn="l"/>
+            <a:r>
+              <a:rPr lang="en-US" sz="1200" dirty="0">
+                <a:solidFill>
+                  <a:srgbClr val="5B6472"/>
+                </a:solidFill>
+                <a:latin typeface="Aptos"/>
+                <a:cs typeface="Aptos"/>
+              </a:rPr>
+              <a:t>29.3%</a:t>
+            </a:r>
+          </a:p>
+        </p:txBody>
+      </p:sp>
+      <p:sp>
+        <p:nvSpPr>
+          <p:cNvPr id="37" name="rect"/>
+          <p:cNvSpPr/>
+          <p:nvPr/>
+        </p:nvSpPr>
+        <p:spPr>
+          <a:xfrm>
+            <a:off x="4421505" y="5594350"/>
+            <a:ext cx="1183005" cy="330200"/>
+          </a:xfrm>
+          <a:prstGeom prst="rect">
+            <a:avLst/>
+          </a:prstGeom>
+          <a:solidFill>
+            <a:srgbClr val="FFFFFF"/>
+          </a:solidFill>
+          <a:ln w="9525">
+            <a:solidFill>
+              <a:srgbClr val="D7D7CC"/>
+            </a:solidFill>
+          </a:ln>
+        </p:spPr>
+      </p:sp>
+      <p:sp>
+        <p:nvSpPr>
+          <p:cNvPr id="38" name="text"/>
+          <p:cNvSpPr txBox="1"/>
+          <p:nvPr/>
+        </p:nvSpPr>
+        <p:spPr>
+          <a:xfrm>
+            <a:off x="4497705" y="5641975"/>
+            <a:ext cx="1030605" cy="254000"/>
+          </a:xfrm>
+          <a:prstGeom prst="rect">
+            <a:avLst/>
+          </a:prstGeom>
+          <a:noFill/>
+          <a:ln>
+            <a:noFill/>
+          </a:ln>
+        </p:spPr>
+        <p:txBody>
+          <a:bodyPr wrap="square" anchor="ctr" lIns="0" tIns="0" rIns="0" bIns="0"/>
+          <a:lstStyle/>
+          <a:p>
+            <a:pPr algn="l"/>
+            <a:r>
+              <a:rPr lang="en-US" sz="1200" dirty="0">
+                <a:solidFill>
+                  <a:srgbClr val="5B6472"/>
+                </a:solidFill>
+                <a:latin typeface="Aptos"/>
+                <a:cs typeface="Aptos"/>
+              </a:rPr>
+              <a:t>25.0%</a:t>
+            </a:r>
+          </a:p>
+        </p:txBody>
+      </p:sp>
+      <p:sp>
+        <p:nvSpPr>
+          <p:cNvPr id="39" name="rect"/>
+          <p:cNvSpPr/>
+          <p:nvPr/>
+        </p:nvSpPr>
+        <p:spPr>
+          <a:xfrm>
+            <a:off x="5604510" y="5594350"/>
+            <a:ext cx="1577340" cy="330200"/>
+          </a:xfrm>
+          <a:prstGeom prst="rect">
+            <a:avLst/>
+          </a:prstGeom>
+          <a:solidFill>
+            <a:srgbClr val="FFFFFF"/>
+          </a:solidFill>
+          <a:ln w="9525">
+            <a:solidFill>
+              <a:srgbClr val="D7D7CC"/>
+            </a:solidFill>
+          </a:ln>
+        </p:spPr>
+      </p:sp>
+      <p:sp>
+        <p:nvSpPr>
+          <p:cNvPr id="40" name="text"/>
+          <p:cNvSpPr txBox="1"/>
+          <p:nvPr/>
+        </p:nvSpPr>
+        <p:spPr>
+          <a:xfrm>
+            <a:off x="5680710" y="5641975"/>
+            <a:ext cx="1424940" cy="254000"/>
+          </a:xfrm>
+          <a:prstGeom prst="rect">
+            <a:avLst/>
+          </a:prstGeom>
+          <a:noFill/>
+          <a:ln>
+            <a:noFill/>
+          </a:ln>
+        </p:spPr>
+        <p:txBody>
+          <a:bodyPr wrap="square" anchor="ctr" lIns="0" tIns="0" rIns="0" bIns="0"/>
+          <a:lstStyle/>
+          <a:p>
+            <a:pPr algn="l"/>
+            <a:r>
+              <a:rPr lang="en-US" sz="1200" dirty="0">
+                <a:solidFill>
+                  <a:srgbClr val="5B6472"/>
+                </a:solidFill>
+                <a:latin typeface="Aptos"/>
+                <a:cs typeface="Aptos"/>
+              </a:rPr>
+              <a:t>17.6 ms</a:t>
+            </a:r>
+          </a:p>
+        </p:txBody>
+      </p:sp>
+      <p:sp>
+        <p:nvSpPr>
+          <p:cNvPr id="41" name="rect"/>
+          <p:cNvSpPr/>
+          <p:nvPr/>
+        </p:nvSpPr>
+        <p:spPr>
+          <a:xfrm>
+            <a:off x="7524750" y="4629150"/>
+            <a:ext cx="4057650" cy="1295400"/>
+          </a:xfrm>
+          <a:prstGeom prst="rect">
+            <a:avLst/>
+          </a:prstGeom>
+          <a:solidFill>
+            <a:srgbClr val="FFFFFF"/>
+          </a:solidFill>
+          <a:ln w="9525">
+            <a:solidFill>
+              <a:srgbClr val="D7D7CC"/>
+            </a:solidFill>
+          </a:ln>
+        </p:spPr>
+      </p:sp>
+      <p:sp>
+        <p:nvSpPr>
+          <p:cNvPr id="42" name="rect"/>
+          <p:cNvSpPr/>
+          <p:nvPr/>
+        </p:nvSpPr>
+        <p:spPr>
+          <a:xfrm>
+            <a:off x="7524750" y="4629150"/>
+            <a:ext cx="57150" cy="1295400"/>
+          </a:xfrm>
+          <a:prstGeom prst="rect">
+            <a:avLst/>
+          </a:prstGeom>
+          <a:solidFill>
+            <a:srgbClr val="B45309"/>
+          </a:solidFill>
+          <a:ln w="9525">
+            <a:solidFill>
+              <a:srgbClr val="B45309"/>
+            </a:solidFill>
+          </a:ln>
+        </p:spPr>
+      </p:sp>
+      <p:sp>
+        <p:nvSpPr>
+          <p:cNvPr id="43" name="text"/>
+          <p:cNvSpPr txBox="1"/>
+          <p:nvPr/>
+        </p:nvSpPr>
+        <p:spPr>
+          <a:xfrm>
+            <a:off x="7696200" y="4762500"/>
+            <a:ext cx="3771900" cy="247650"/>
+          </a:xfrm>
+          <a:prstGeom prst="rect">
+            <a:avLst/>
+          </a:prstGeom>
+          <a:noFill/>
+          <a:ln>
+            <a:noFill/>
+          </a:ln>
+        </p:spPr>
+        <p:txBody>
+          <a:bodyPr wrap="square" anchor="t" lIns="0" tIns="0" rIns="0" bIns="0"/>
+          <a:lstStyle/>
+          <a:p>
+            <a:pPr algn="l"/>
+            <a:r>
+              <a:rPr lang="en-US" sz="1500" b="1" dirty="0">
+                <a:solidFill>
+                  <a:srgbClr val="111827"/>
+                </a:solidFill>
+                <a:latin typeface="Aptos"/>
+                <a:cs typeface="Aptos"/>
+              </a:rPr>
+              <a:t>Reading</a:t>
+            </a:r>
+          </a:p>
+        </p:txBody>
+      </p:sp>
+      <p:sp>
+        <p:nvSpPr>
+          <p:cNvPr id="44" name="text"/>
+          <p:cNvSpPr txBox="1"/>
+          <p:nvPr/>
+        </p:nvSpPr>
+        <p:spPr>
+          <a:xfrm>
+            <a:off x="7696200" y="5048250"/>
+            <a:ext cx="3752850" cy="762000"/>
+          </a:xfrm>
+          <a:prstGeom prst="rect">
+            <a:avLst/>
+          </a:prstGeom>
+          <a:noFill/>
+          <a:ln>
+            <a:noFill/>
+          </a:ln>
+        </p:spPr>
+        <p:txBody>
+          <a:bodyPr wrap="square" anchor="t" lIns="0" tIns="0" rIns="0" bIns="0"/>
+          <a:lstStyle/>
+          <a:p>
+            <a:pPr algn="l"/>
+            <a:r>
+              <a:rPr lang="en-US" sz="1200" dirty="0">
+                <a:solidFill>
+                  <a:srgbClr val="5B6472"/>
+                </a:solidFill>
+                <a:latin typeface="Aptos"/>
+                <a:cs typeface="Aptos"/>
+              </a:rPr>
+              <a:t>31/32 IEPS points sit on the vase edge; greedy SCF closes the contour in ~15 ms - consistent with the paper's low-complexity claim (Table V: 37 ms vs 363 ms for Snake). The improved-IEPS extension does not transfer here (F1 25%) - reported, not hidden.</a:t>
+            </a:r>
+          </a:p>
+        </p:txBody>
+      </p:sp>
+      <p:sp>
+        <p:nvSpPr>
+          <p:cNvPr id="45" name="text"/>
+          <p:cNvSpPr txBox="1"/>
+          <p:nvPr/>
+        </p:nvSpPr>
+        <p:spPr>
+          <a:xfrm>
+            <a:off x="609600" y="6553200"/>
+            <a:ext cx="5905500" cy="171450"/>
+          </a:xfrm>
+          <a:prstGeom prst="rect">
+            <a:avLst/>
+          </a:prstGeom>
+          <a:noFill/>
+          <a:ln>
+            <a:noFill/>
+          </a:ln>
+        </p:spPr>
+        <p:txBody>
+          <a:bodyPr wrap="square" anchor="t" lIns="0" tIns="0" rIns="0" bIns="0"/>
+          <a:lstStyle/>
+          <a:p>
+            <a:pPr algn="l"/>
+            <a:r>
+              <a:rPr lang="en-US" sz="1000" dirty="0">
+                <a:solidFill>
+                  <a:srgbClr val="727B85"/>
+                </a:solidFill>
+                <a:latin typeface="Aptos"/>
+                <a:cs typeface="Aptos"/>
+              </a:rPr>
+              <a:t>IEPS + SCF reproducibility study  |  Parth Goswami  |  10 / 11</a:t>
+            </a:r>
+          </a:p>
+        </p:txBody>
+      </p:sp>
+      <p:sp>
+        <p:nvSpPr>
+          <p:cNvPr id="46" name="text"/>
+          <p:cNvSpPr txBox="1"/>
+          <p:nvPr/>
+        </p:nvSpPr>
+        <p:spPr>
+          <a:xfrm>
+            <a:off x="7239000" y="6553200"/>
+            <a:ext cx="4343400" cy="171450"/>
+          </a:xfrm>
+          <a:prstGeom prst="rect">
+            <a:avLst/>
+          </a:prstGeom>
+          <a:noFill/>
+          <a:ln>
+            <a:noFill/>
+          </a:ln>
+        </p:spPr>
+        <p:txBody>
+          <a:bodyPr wrap="square" anchor="t" lIns="0" tIns="0" rIns="0" bIns="0"/>
+          <a:lstStyle/>
+          <a:p>
+            <a:pPr algn="r"/>
+            <a:r>
+              <a:rPr lang="en-US" sz="1000" dirty="0">
+                <a:solidFill>
+                  <a:srgbClr val="727B85"/>
+                </a:solidFill>
+                <a:latin typeface="Aptos"/>
+                <a:cs typeface="Aptos"/>
+              </a:rPr>
+              <a:t>Hsu et al., ICARCV 2010 [1]</a:t>
+            </a:r>
+          </a:p>
+        </p:txBody>
+      </p:sp>
+    </p:spTree>
+  </p:cSld>
+  <p:clrMapOvr>
+    <a:masterClrMapping/>
+  </p:clrMapOvr>
+</p:sld>
+</file>
+
+<file path=ppt/slides/slide11.xml><?xml version="1.0" encoding="utf-8"?>
+<p:sld xmlns:a="http://schemas.openxmlformats.org/drawingml/2006/main" xmlns:r="http://schemas.openxmlformats.org/officeDocument/2006/relationships" xmlns:p="http://schemas.openxmlformats.org/presentationml/2006/main">
+  <p:cSld>
+    <p:spTree>
+      <p:nvGrpSpPr>
+        <p:cNvPr id="1" name=""/>
+        <p:cNvGrpSpPr/>
+        <p:nvPr/>
+      </p:nvGrpSpPr>
+      <p:grpSpPr>
+        <a:xfrm>
+          <a:off x="0" y="0"/>
+          <a:ext cx="0" cy="0"/>
+          <a:chOff x="0" y="0"/>
+          <a:chExt cx="0" cy="0"/>
+        </a:xfrm>
+      </p:grpSpPr>
+      <p:sp>
+        <p:nvSpPr>
+          <p:cNvPr id="2" name="rect"/>
+          <p:cNvSpPr/>
+          <p:nvPr/>
+        </p:nvSpPr>
+        <p:spPr>
+          <a:xfrm>
+            <a:off x="0" y="0"/>
+            <a:ext cx="12192000" cy="6858000"/>
+          </a:xfrm>
+          <a:prstGeom prst="rect">
+            <a:avLst/>
+          </a:prstGeom>
+          <a:solidFill>
+            <a:srgbClr val="F7F7F2"/>
+          </a:solidFill>
+          <a:ln w="9525">
+            <a:solidFill>
+              <a:srgbClr val="F7F7F2"/>
+            </a:solidFill>
+          </a:ln>
+        </p:spPr>
+      </p:sp>
+      <p:sp>
+        <p:nvSpPr>
+          <p:cNvPr id="3" name="text"/>
+          <p:cNvSpPr txBox="1"/>
+          <p:nvPr/>
+        </p:nvSpPr>
+        <p:spPr>
+          <a:xfrm>
+            <a:off x="609600" y="323850"/>
+            <a:ext cx="10477500" cy="190500"/>
+          </a:xfrm>
+          <a:prstGeom prst="rect">
+            <a:avLst/>
+          </a:prstGeom>
+          <a:noFill/>
+          <a:ln>
+            <a:noFill/>
+          </a:ln>
+        </p:spPr>
+        <p:txBody>
+          <a:bodyPr wrap="square" anchor="t" lIns="0" tIns="0" rIns="0" bIns="0"/>
+          <a:lstStyle/>
+          <a:p>
+            <a:pPr algn="l"/>
+            <a:r>
+              <a:rPr lang="en-US" sz="1200" b="1" dirty="0">
+                <a:solidFill>
+                  <a:srgbClr val="0F766E"/>
+                </a:solidFill>
+                <a:latin typeface="Aptos"/>
+                <a:cs typeface="Aptos"/>
+              </a:rPr>
+              <a:t>CONCLUSION</a:t>
+            </a:r>
+          </a:p>
+        </p:txBody>
+      </p:sp>
+      <p:sp>
+        <p:nvSpPr>
+          <p:cNvPr id="4" name="text"/>
+          <p:cNvSpPr txBox="1"/>
+          <p:nvPr/>
+        </p:nvSpPr>
+        <p:spPr>
+          <a:xfrm>
+            <a:off x="609600" y="552450"/>
+            <a:ext cx="10972800" cy="419100"/>
+          </a:xfrm>
+          <a:prstGeom prst="rect">
+            <a:avLst/>
+          </a:prstGeom>
+          <a:noFill/>
+          <a:ln>
+            <a:noFill/>
+          </a:ln>
+        </p:spPr>
+        <p:txBody>
+          <a:bodyPr wrap="square" anchor="t" lIns="0" tIns="0" rIns="0" bIns="0"/>
+          <a:lstStyle/>
+          <a:p>
+            <a:pPr algn="l"/>
+            <a:r>
+              <a:rPr lang="en-US" sz="2900" b="1" dirty="0">
+                <a:solidFill>
+                  <a:srgbClr val="111827"/>
+                </a:solidFill>
+                <a:latin typeface="Aptos"/>
+                <a:cs typeface="Aptos"/>
+              </a:rPr>
+              <a:t>The method reproduces - once the missing rules are written down</a:t>
+            </a:r>
+          </a:p>
+        </p:txBody>
+      </p:sp>
+      <p:sp>
+        <p:nvSpPr>
+          <p:cNvPr id="5" name="text"/>
+          <p:cNvSpPr txBox="1"/>
+          <p:nvPr/>
+        </p:nvSpPr>
+        <p:spPr>
+          <a:xfrm>
+            <a:off x="609600" y="990600"/>
+            <a:ext cx="10972800" cy="381000"/>
+          </a:xfrm>
+          <a:prstGeom prst="rect">
+            <a:avLst/>
+          </a:prstGeom>
+          <a:noFill/>
+          <a:ln>
+            <a:noFill/>
+          </a:ln>
+        </p:spPr>
+        <p:txBody>
+          <a:bodyPr wrap="square" anchor="t" lIns="0" tIns="0" rIns="0" bIns="0"/>
+          <a:lstStyle/>
+          <a:p>
+            <a:pPr algn="l"/>
+            <a:r>
+              <a:rPr lang="en-US" sz="1300" dirty="0">
+                <a:solidFill>
+                  <a:srgbClr val="5B6472"/>
+                </a:solidFill>
+                <a:latin typeface="Aptos"/>
+                <a:cs typeface="Aptos"/>
+              </a:rPr>
+              <a:t>The reproducibility audit is the contribution: assumptions were made explicit, implemented, and measured.</a:t>
+            </a:r>
+          </a:p>
+        </p:txBody>
+      </p:sp>
+      <p:sp>
+        <p:nvSpPr>
+          <p:cNvPr id="6" name="rect"/>
+          <p:cNvSpPr/>
+          <p:nvPr/>
+        </p:nvSpPr>
+        <p:spPr>
+          <a:xfrm>
+            <a:off x="609600" y="1428750"/>
+            <a:ext cx="10972800" cy="9525"/>
+          </a:xfrm>
+          <a:prstGeom prst="rect">
+            <a:avLst/>
+          </a:prstGeom>
+          <a:solidFill>
+            <a:srgbClr val="D7D7CC"/>
+          </a:solidFill>
+          <a:ln w="9525">
+            <a:solidFill>
+              <a:srgbClr val="D7D7CC"/>
+            </a:solidFill>
+          </a:ln>
+        </p:spPr>
+      </p:sp>
       <p:sp>
         <p:nvSpPr>
           <p:cNvPr id="7" name="rect"/>
@@ -1332,7 +2748,7 @@
                 <a:latin typeface="Aptos"/>
                 <a:cs typeface="Aptos"/>
               </a:rPr>
-              <a:t>IEPS + SCF reproducibility study  |  Parth Goswami  |  10 / 10</a:t>
+              <a:t>IEPS + SCF reproducibility study  |  Parth Goswami  |  11 / 11</a:t>
             </a:r>
           </a:p>
         </p:txBody>
@@ -2054,7 +3470,7 @@
                 <a:latin typeface="Aptos"/>
                 <a:cs typeface="Aptos"/>
               </a:rPr>
-              <a:t>IEPS + SCF reproducibility study  |  Parth Goswami  |  02 / 10</a:t>
+              <a:t>IEPS + SCF reproducibility study  |  Parth Goswami  |  02 / 11</a:t>
             </a:r>
           </a:p>
         </p:txBody>
@@ -3099,7 +4515,7 @@
                 <a:latin typeface="Aptos"/>
                 <a:cs typeface="Aptos"/>
               </a:rPr>
-              <a:t>IEPS + SCF reproducibility study  |  Parth Goswami  |  03 / 10</a:t>
+              <a:t>IEPS + SCF reproducibility study  |  Parth Goswami  |  03 / 11</a:t>
             </a:r>
           </a:p>
         </p:txBody>
@@ -4085,7 +5501,7 @@
                 <a:latin typeface="Aptos"/>
                 <a:cs typeface="Aptos"/>
               </a:rPr>
-              <a:t>IEPS + SCF reproducibility study  |  Parth Goswami  |  04 / 10</a:t>
+              <a:t>IEPS + SCF reproducibility study  |  Parth Goswami  |  04 / 11</a:t>
             </a:r>
           </a:p>
         </p:txBody>
@@ -5929,7 +7345,7 @@
                 <a:latin typeface="Aptos"/>
                 <a:cs typeface="Aptos"/>
               </a:rPr>
-              <a:t>IEPS + SCF reproducibility study  |  Parth Goswami  |  05 / 10</a:t>
+              <a:t>IEPS + SCF reproducibility study  |  Parth Goswami  |  05 / 11</a:t>
             </a:r>
           </a:p>
         </p:txBody>
@@ -7786,7 +9202,7 @@
                 <a:latin typeface="Aptos"/>
                 <a:cs typeface="Aptos"/>
               </a:rPr>
-              <a:t>IEPS + SCF reproducibility study  |  Parth Goswami  |  06 / 10</a:t>
+              <a:t>IEPS + SCF reproducibility study  |  Parth Goswami  |  06 / 11</a:t>
             </a:r>
           </a:p>
         </p:txBody>
@@ -8919,7 +10335,7 @@
                 <a:latin typeface="Aptos"/>
                 <a:cs typeface="Aptos"/>
               </a:rPr>
-              <a:t>IEPS + SCF reproducibility study  |  Parth Goswami  |  07 / 10</a:t>
+              <a:t>IEPS + SCF reproducibility study  |  Parth Goswami  |  07 / 11</a:t>
             </a:r>
           </a:p>
         </p:txBody>
@@ -10089,7 +11505,7 @@
                 <a:latin typeface="Aptos"/>
                 <a:cs typeface="Aptos"/>
               </a:rPr>
-              <a:t>IEPS + SCF reproducibility study  |  Parth Goswami  |  08 / 10</a:t>
+              <a:t>IEPS + SCF reproducibility study  |  Parth Goswami  |  08 / 11</a:t>
             </a:r>
           </a:p>
         </p:txBody>
@@ -13421,7 +14837,7 @@
                 <a:latin typeface="Aptos"/>
                 <a:cs typeface="Aptos"/>
               </a:rPr>
-              <a:t>Real vase + honesty notes</a:t>
+              <a:t>Honesty notes</a:t>
             </a:r>
           </a:p>
         </p:txBody>
@@ -13458,7 +14874,7 @@
                 <a:latin typeface="Aptos"/>
                 <a:cs typeface="Aptos"/>
               </a:rPr>
-              <a:t>Real vase (Otsu proxy mask): paper-mode F1 93.8%. Yuen/Snake/Chen comparisons are labeled approximations; on these synthetic shapes they tie or nearly tie (Chen = proposed SCF at every SNR), so they are context, not evidence of the paper's reported gaps.</a:t>
+              <a:t>Yuen/Snake/Chen comparisons are labeled approximations; on these synthetic shapes they tie or nearly tie (Chen = proposed SCF at every SNR), so they are context, not evidence of the paper's reported gaps. The real-image test follows on the next slide.</a:t>
             </a:r>
           </a:p>
         </p:txBody>
@@ -13532,7 +14948,7 @@
                 <a:latin typeface="Aptos"/>
                 <a:cs typeface="Aptos"/>
               </a:rPr>
-              <a:t>IEPS + SCF reproducibility study  |  Parth Goswami  |  09 / 10</a:t>
+              <a:t>IEPS + SCF reproducibility study  |  Parth Goswami  |  09 / 11</a:t>
             </a:r>
           </a:p>
         </p:txBody>

</xml_diff>

<commit_message>
Update final presentation files with new content and images
</commit_message>
<xml_diff>
--- a/outputs/ieps_scf_final_presentation.pptx
+++ b/outputs/ieps_scf_final_presentation.pptx
@@ -1290,7 +1290,7 @@
                 <a:latin typeface="Aptos"/>
                 <a:cs typeface="Aptos"/>
               </a:rPr>
-              <a:t>14.8 ms</a:t>
+              <a:t>7.2 ms</a:t>
             </a:r>
           </a:p>
         </p:txBody>
@@ -1534,7 +1534,7 @@
                 <a:latin typeface="Aptos"/>
                 <a:cs typeface="Aptos"/>
               </a:rPr>
-              <a:t>136.7 ms</a:t>
+              <a:t>105.1 ms</a:t>
             </a:r>
           </a:p>
         </p:txBody>
@@ -1778,7 +1778,7 @@
                 <a:latin typeface="Aptos"/>
                 <a:cs typeface="Aptos"/>
               </a:rPr>
-              <a:t>17.6 ms</a:t>
+              <a:t>37.0 ms</a:t>
             </a:r>
           </a:p>
         </p:txBody>
@@ -12580,7 +12580,7 @@
                 <a:latin typeface="Aptos"/>
                 <a:cs typeface="Aptos"/>
               </a:rPr>
-              <a:t>11.7 ms</a:t>
+              <a:t>8.5 ms</a:t>
             </a:r>
           </a:p>
         </p:txBody>
@@ -13007,7 +13007,7 @@
                 <a:latin typeface="Aptos"/>
                 <a:cs typeface="Aptos"/>
               </a:rPr>
-              <a:t>14.4 ms</a:t>
+              <a:t>7.6 ms</a:t>
             </a:r>
           </a:p>
         </p:txBody>
@@ -13434,7 +13434,7 @@
                 <a:latin typeface="Aptos"/>
                 <a:cs typeface="Aptos"/>
               </a:rPr>
-              <a:t>9.8 ms</a:t>
+              <a:t>8.0 ms</a:t>
             </a:r>
           </a:p>
         </p:txBody>
@@ -13861,7 +13861,7 @@
                 <a:latin typeface="Aptos"/>
                 <a:cs typeface="Aptos"/>
               </a:rPr>
-              <a:t>9.7 ms</a:t>
+              <a:t>8.2 ms</a:t>
             </a:r>
           </a:p>
         </p:txBody>

</xml_diff>

<commit_message>
Update performance metrics and runtime results across various tables
- Adjusted runtime values for Snake initialization in `paper_comparison_results.csv` and `paper_snake_initialization_comparison.csv`.
- Updated F1 scores and runtime metrics for SCF tracing in `paper_comparison_results.csv` and `paper_scf_chen_comparison.csv`.
- Revised runtime and accuracy metrics for the real vase comparison in `paper_vase_method_comparison.csv` and `real_vase_results.csv`.
- Enhanced parameter study results with updated elapsed times in `parameter_study.csv`.
- Modified runtime results for various cases in `runtime_results.csv` to reflect improved performance.
</commit_message>
<xml_diff>
--- a/outputs/ieps_scf_final_presentation.pptx
+++ b/outputs/ieps_scf_final_presentation.pptx
@@ -1290,7 +1290,7 @@
                 <a:latin typeface="Aptos"/>
                 <a:cs typeface="Aptos"/>
               </a:rPr>
-              <a:t>7.2 ms</a:t>
+              <a:t>8.9 ms</a:t>
             </a:r>
           </a:p>
         </p:txBody>
@@ -1534,7 +1534,7 @@
                 <a:latin typeface="Aptos"/>
                 <a:cs typeface="Aptos"/>
               </a:rPr>
-              <a:t>105.1 ms</a:t>
+              <a:t>124.1 ms</a:t>
             </a:r>
           </a:p>
         </p:txBody>
@@ -1778,7 +1778,7 @@
                 <a:latin typeface="Aptos"/>
                 <a:cs typeface="Aptos"/>
               </a:rPr>
-              <a:t>37.0 ms</a:t>
+              <a:t>18.8 ms</a:t>
             </a:r>
           </a:p>
         </p:txBody>
@@ -12580,7 +12580,7 @@
                 <a:latin typeface="Aptos"/>
                 <a:cs typeface="Aptos"/>
               </a:rPr>
-              <a:t>8.5 ms</a:t>
+              <a:t>9.5 ms</a:t>
             </a:r>
           </a:p>
         </p:txBody>
@@ -13007,7 +13007,7 @@
                 <a:latin typeface="Aptos"/>
                 <a:cs typeface="Aptos"/>
               </a:rPr>
-              <a:t>7.6 ms</a:t>
+              <a:t>8.4 ms</a:t>
             </a:r>
           </a:p>
         </p:txBody>
@@ -13434,7 +13434,7 @@
                 <a:latin typeface="Aptos"/>
                 <a:cs typeface="Aptos"/>
               </a:rPr>
-              <a:t>8.0 ms</a:t>
+              <a:t>8.2 ms</a:t>
             </a:r>
           </a:p>
         </p:txBody>
@@ -13861,7 +13861,7 @@
                 <a:latin typeface="Aptos"/>
                 <a:cs typeface="Aptos"/>
               </a:rPr>
-              <a:t>8.2 ms</a:t>
+              <a:t>9.5 ms</a:t>
             </a:r>
           </a:p>
         </p:txBody>

</xml_diff>